<commit_message>
Update Statistics for Data Science presentation file
</commit_message>
<xml_diff>
--- a/My Note and Practice/Statistics/Statistics for Data Science.pptx
+++ b/My Note and Practice/Statistics/Statistics for Data Science.pptx
@@ -215,7 +215,7 @@
           <a:p>
             <a:fld id="{1AD595E0-8E92-4D4C-8397-7309550C394C}" type="datetimeFigureOut">
               <a:rPr lang="en-US" smtClean="0"/>
-              <a:t>11/4/2025</a:t>
+              <a:t>11/30/2025</a:t>
             </a:fld>
             <a:endParaRPr lang="en-US"/>
           </a:p>
@@ -1540,7 +1540,7 @@
           <a:p>
             <a:fld id="{ABED6CD1-0E84-4FDB-B561-E6E954EE1C25}" type="datetimeFigureOut">
               <a:rPr lang="en-US" smtClean="0"/>
-              <a:t>11/4/2025</a:t>
+              <a:t>11/30/2025</a:t>
             </a:fld>
             <a:endParaRPr lang="en-US"/>
           </a:p>
@@ -1738,7 +1738,7 @@
           <a:p>
             <a:fld id="{ABED6CD1-0E84-4FDB-B561-E6E954EE1C25}" type="datetimeFigureOut">
               <a:rPr lang="en-US" smtClean="0"/>
-              <a:t>11/4/2025</a:t>
+              <a:t>11/30/2025</a:t>
             </a:fld>
             <a:endParaRPr lang="en-US"/>
           </a:p>
@@ -1946,7 +1946,7 @@
           <a:p>
             <a:fld id="{ABED6CD1-0E84-4FDB-B561-E6E954EE1C25}" type="datetimeFigureOut">
               <a:rPr lang="en-US" smtClean="0"/>
-              <a:t>11/4/2025</a:t>
+              <a:t>11/30/2025</a:t>
             </a:fld>
             <a:endParaRPr lang="en-US"/>
           </a:p>
@@ -2144,7 +2144,7 @@
           <a:p>
             <a:fld id="{ABED6CD1-0E84-4FDB-B561-E6E954EE1C25}" type="datetimeFigureOut">
               <a:rPr lang="en-US" smtClean="0"/>
-              <a:t>11/4/2025</a:t>
+              <a:t>11/30/2025</a:t>
             </a:fld>
             <a:endParaRPr lang="en-US"/>
           </a:p>
@@ -2419,7 +2419,7 @@
           <a:p>
             <a:fld id="{ABED6CD1-0E84-4FDB-B561-E6E954EE1C25}" type="datetimeFigureOut">
               <a:rPr lang="en-US" smtClean="0"/>
-              <a:t>11/4/2025</a:t>
+              <a:t>11/30/2025</a:t>
             </a:fld>
             <a:endParaRPr lang="en-US"/>
           </a:p>
@@ -2684,7 +2684,7 @@
           <a:p>
             <a:fld id="{ABED6CD1-0E84-4FDB-B561-E6E954EE1C25}" type="datetimeFigureOut">
               <a:rPr lang="en-US" smtClean="0"/>
-              <a:t>11/4/2025</a:t>
+              <a:t>11/30/2025</a:t>
             </a:fld>
             <a:endParaRPr lang="en-US"/>
           </a:p>
@@ -3096,7 +3096,7 @@
           <a:p>
             <a:fld id="{ABED6CD1-0E84-4FDB-B561-E6E954EE1C25}" type="datetimeFigureOut">
               <a:rPr lang="en-US" smtClean="0"/>
-              <a:t>11/4/2025</a:t>
+              <a:t>11/30/2025</a:t>
             </a:fld>
             <a:endParaRPr lang="en-US"/>
           </a:p>
@@ -3237,7 +3237,7 @@
           <a:p>
             <a:fld id="{ABED6CD1-0E84-4FDB-B561-E6E954EE1C25}" type="datetimeFigureOut">
               <a:rPr lang="en-US" smtClean="0"/>
-              <a:t>11/4/2025</a:t>
+              <a:t>11/30/2025</a:t>
             </a:fld>
             <a:endParaRPr lang="en-US"/>
           </a:p>
@@ -3350,7 +3350,7 @@
           <a:p>
             <a:fld id="{ABED6CD1-0E84-4FDB-B561-E6E954EE1C25}" type="datetimeFigureOut">
               <a:rPr lang="en-US" smtClean="0"/>
-              <a:t>11/4/2025</a:t>
+              <a:t>11/30/2025</a:t>
             </a:fld>
             <a:endParaRPr lang="en-US"/>
           </a:p>
@@ -3661,7 +3661,7 @@
           <a:p>
             <a:fld id="{ABED6CD1-0E84-4FDB-B561-E6E954EE1C25}" type="datetimeFigureOut">
               <a:rPr lang="en-US" smtClean="0"/>
-              <a:t>11/4/2025</a:t>
+              <a:t>11/30/2025</a:t>
             </a:fld>
             <a:endParaRPr lang="en-US"/>
           </a:p>
@@ -3949,7 +3949,7 @@
           <a:p>
             <a:fld id="{ABED6CD1-0E84-4FDB-B561-E6E954EE1C25}" type="datetimeFigureOut">
               <a:rPr lang="en-US" smtClean="0"/>
-              <a:t>11/4/2025</a:t>
+              <a:t>11/30/2025</a:t>
             </a:fld>
             <a:endParaRPr lang="en-US"/>
           </a:p>
@@ -4190,7 +4190,7 @@
           <a:p>
             <a:fld id="{ABED6CD1-0E84-4FDB-B561-E6E954EE1C25}" type="datetimeFigureOut">
               <a:rPr lang="en-US" smtClean="0"/>
-              <a:t>11/4/2025</a:t>
+              <a:t>11/30/2025</a:t>
             </a:fld>
             <a:endParaRPr lang="en-US"/>
           </a:p>
@@ -6527,7 +6527,7 @@
         <p:spPr>
           <a:xfrm>
             <a:off x="6197688" y="2016899"/>
-            <a:ext cx="2244182" cy="923330"/>
+            <a:ext cx="2244182" cy="1200329"/>
           </a:xfrm>
           <a:prstGeom prst="rect">
             <a:avLst/>
@@ -6557,12 +6557,20 @@
           <a:p>
             <a:pPr algn="ctr"/>
             <a:r>
+              <a:rPr lang="en-US">
+                <a:latin typeface="Open Sans" pitchFamily="2" charset="0"/>
+                <a:ea typeface="Open Sans" pitchFamily="2" charset="0"/>
+                <a:cs typeface="Open Sans" pitchFamily="2" charset="0"/>
+              </a:rPr>
+              <a:t>Data </a:t>
+            </a:r>
+            <a:r>
               <a:rPr lang="en-US" dirty="0">
                 <a:latin typeface="Open Sans" pitchFamily="2" charset="0"/>
                 <a:ea typeface="Open Sans" pitchFamily="2" charset="0"/>
                 <a:cs typeface="Open Sans" pitchFamily="2" charset="0"/>
               </a:rPr>
-              <a:t>D Based on Nature </a:t>
+              <a:t>Based on Nature </a:t>
             </a:r>
           </a:p>
           <a:p>

</xml_diff>